<commit_message>
feat(deck): add phase ratchet evaluators slide to telemetry deck
Slide 12 shows all 6 phases with upstream, max iterations, and key
checks. Callout shows 5-criteria rubric and ratchet rule. Dynamic
slide total auto-updated to 12.

Co-Authored-By: Claude Opus 4.7 (1M context) <noreply@anthropic.com>
</commit_message>
<xml_diff>
--- a/matrices.pptx
+++ b/matrices.pptx
@@ -16,6 +16,7 @@
     <p:sldId id="264" r:id="rId15"/>
     <p:sldId id="265" r:id="rId16"/>
     <p:sldId id="266" r:id="rId17"/>
+    <p:sldId id="267" r:id="rId18"/>
   </p:sldIdLst>
   <p:sldSz cx="9144000" cy="5143500" type="screen4x3"/>
   <p:notesSz cx="6858000" cy="9144000"/>
@@ -3319,7 +3320,7 @@
                 </a:solidFill>
                 <a:latin typeface="Calibri"/>
               </a:rPr>
-              <a:t>1 / 11</a:t>
+              <a:t>1 / 12</a:t>
             </a:r>
           </a:p>
         </p:txBody>
@@ -4421,7 +4422,7 @@
                 </a:solidFill>
                 <a:latin typeface="Calibri"/>
               </a:rPr>
-              <a:t>10 / 11</a:t>
+              <a:t>10 / 12</a:t>
             </a:r>
           </a:p>
         </p:txBody>
@@ -5269,7 +5270,7 @@
                 </a:solidFill>
                 <a:latin typeface="Calibri"/>
               </a:rPr>
-              <a:t>11 / 11</a:t>
+              <a:t>11 / 12</a:t>
             </a:r>
           </a:p>
         </p:txBody>
@@ -6103,6 +6104,1059 @@
                 <a:latin typeface="Calibri"/>
               </a:rPr>
               <a:t>Remote: change OTEL_EXPORTER_OTLP_ENDPOINT + HARNESS_PUSHGATEWAY_URL in settings.json.</a:t>
+            </a:r>
+          </a:p>
+        </p:txBody>
+      </p:sp>
+    </p:spTree>
+  </p:cSld>
+  <p:clrMapOvr>
+    <a:masterClrMapping/>
+  </p:clrMapOvr>
+</p:sld>
+</file>
+
+<file path=ppt/slides/slide12.xml><?xml version="1.0" encoding="utf-8"?>
+<p:sld xmlns:a="http://schemas.openxmlformats.org/drawingml/2006/main" xmlns:p="http://schemas.openxmlformats.org/presentationml/2006/main" xmlns:r="http://schemas.openxmlformats.org/officeDocument/2006/relationships">
+  <p:cSld>
+    <p:spTree>
+      <p:nvGrpSpPr>
+        <p:cNvPr id="1" name=""/>
+        <p:cNvGrpSpPr/>
+        <p:nvPr/>
+      </p:nvGrpSpPr>
+      <p:grpSpPr/>
+      <p:sp>
+        <p:nvSpPr>
+          <p:cNvPr id="2" name="Rectangle 1"/>
+          <p:cNvSpPr/>
+          <p:nvPr/>
+        </p:nvSpPr>
+        <p:spPr>
+          <a:xfrm>
+            <a:off x="0" y="0"/>
+            <a:ext cx="9144000" cy="5143500"/>
+          </a:xfrm>
+          <a:prstGeom prst="rect">
+            <a:avLst/>
+          </a:prstGeom>
+          <a:solidFill>
+            <a:srgbClr val="0F172A"/>
+          </a:solidFill>
+          <a:ln>
+            <a:noFill/>
+          </a:ln>
+        </p:spPr>
+        <p:style>
+          <a:lnRef idx="1">
+            <a:schemeClr val="accent1"/>
+          </a:lnRef>
+          <a:fillRef idx="3">
+            <a:schemeClr val="accent1"/>
+          </a:fillRef>
+          <a:effectRef idx="2">
+            <a:schemeClr val="accent1"/>
+          </a:effectRef>
+          <a:fontRef idx="minor">
+            <a:schemeClr val="lt1"/>
+          </a:fontRef>
+        </p:style>
+        <p:txBody>
+          <a:bodyPr rtlCol="0" anchor="ctr"/>
+          <a:lstStyle/>
+          <a:p>
+            <a:pPr algn="ctr"/>
+          </a:p>
+        </p:txBody>
+      </p:sp>
+      <p:sp>
+        <p:nvSpPr>
+          <p:cNvPr id="3" name="Rectangle 2"/>
+          <p:cNvSpPr/>
+          <p:nvPr/>
+        </p:nvSpPr>
+        <p:spPr>
+          <a:xfrm>
+            <a:off x="0" y="0"/>
+            <a:ext cx="9144000" cy="54864"/>
+          </a:xfrm>
+          <a:prstGeom prst="rect">
+            <a:avLst/>
+          </a:prstGeom>
+          <a:solidFill>
+            <a:srgbClr val="38BDF8"/>
+          </a:solidFill>
+          <a:ln>
+            <a:noFill/>
+          </a:ln>
+        </p:spPr>
+        <p:style>
+          <a:lnRef idx="1">
+            <a:schemeClr val="accent1"/>
+          </a:lnRef>
+          <a:fillRef idx="3">
+            <a:schemeClr val="accent1"/>
+          </a:fillRef>
+          <a:effectRef idx="2">
+            <a:schemeClr val="accent1"/>
+          </a:effectRef>
+          <a:fontRef idx="minor">
+            <a:schemeClr val="lt1"/>
+          </a:fontRef>
+        </p:style>
+        <p:txBody>
+          <a:bodyPr rtlCol="0" anchor="ctr"/>
+          <a:lstStyle/>
+          <a:p>
+            <a:pPr algn="ctr"/>
+          </a:p>
+        </p:txBody>
+      </p:sp>
+      <p:sp>
+        <p:nvSpPr>
+          <p:cNvPr id="4" name="TextBox 3"/>
+          <p:cNvSpPr txBox="1"/>
+          <p:nvPr/>
+        </p:nvSpPr>
+        <p:spPr>
+          <a:xfrm>
+            <a:off x="411480" y="182880"/>
+            <a:ext cx="8321040" cy="502920"/>
+          </a:xfrm>
+          <a:prstGeom prst="rect">
+            <a:avLst/>
+          </a:prstGeom>
+          <a:noFill/>
+        </p:spPr>
+        <p:txBody>
+          <a:bodyPr wrap="square" lIns="0" rIns="0" tIns="0" bIns="0" anchor="t">
+            <a:spAutoFit/>
+          </a:bodyPr>
+          <a:lstStyle/>
+          <a:p>
+            <a:pPr algn="l"/>
+            <a:r>
+              <a:rPr sz="2600" b="1">
+                <a:solidFill>
+                  <a:srgbClr val="F8FAFC"/>
+                </a:solidFill>
+                <a:latin typeface="Calibri"/>
+              </a:rPr>
+              <a:t>Phase Ratchet Evaluators</a:t>
+            </a:r>
+          </a:p>
+        </p:txBody>
+      </p:sp>
+      <p:sp>
+        <p:nvSpPr>
+          <p:cNvPr id="5" name="TextBox 4"/>
+          <p:cNvSpPr txBox="1"/>
+          <p:nvPr/>
+        </p:nvSpPr>
+        <p:spPr>
+          <a:xfrm>
+            <a:off x="411480" y="713232"/>
+            <a:ext cx="8321040" cy="320040"/>
+          </a:xfrm>
+          <a:prstGeom prst="rect">
+            <a:avLst/>
+          </a:prstGeom>
+          <a:noFill/>
+        </p:spPr>
+        <p:txBody>
+          <a:bodyPr wrap="square" lIns="0" rIns="0" tIns="0" bIns="0" anchor="t">
+            <a:spAutoFit/>
+          </a:bodyPr>
+          <a:lstStyle/>
+          <a:p>
+            <a:pPr algn="l"/>
+            <a:r>
+              <a:rPr sz="1200" b="0">
+                <a:solidFill>
+                  <a:srgbClr val="38BDF8"/>
+                </a:solidFill>
+                <a:latin typeface="Calibri"/>
+              </a:rPr>
+              <a:t>Opus 4.6 generates · Opus 4.7 validates · Ratchet: scores only go up · Human gate preserved</a:t>
+            </a:r>
+          </a:p>
+        </p:txBody>
+      </p:sp>
+      <p:sp>
+        <p:nvSpPr>
+          <p:cNvPr id="6" name="TextBox 5"/>
+          <p:cNvSpPr txBox="1"/>
+          <p:nvPr/>
+        </p:nvSpPr>
+        <p:spPr>
+          <a:xfrm>
+            <a:off x="411480" y="4846320"/>
+            <a:ext cx="5943600" cy="182880"/>
+          </a:xfrm>
+          <a:prstGeom prst="rect">
+            <a:avLst/>
+          </a:prstGeom>
+          <a:noFill/>
+        </p:spPr>
+        <p:txBody>
+          <a:bodyPr wrap="square" lIns="0" rIns="0" tIns="0" bIns="0" anchor="t">
+            <a:spAutoFit/>
+          </a:bodyPr>
+          <a:lstStyle/>
+          <a:p>
+            <a:pPr algn="l"/>
+            <a:r>
+              <a:rPr sz="800" b="0">
+                <a:solidFill>
+                  <a:srgbClr val="94A3B8"/>
+                </a:solidFill>
+                <a:latin typeface="Calibri"/>
+              </a:rPr>
+              <a:t>Claude Harness Engine v4   ·   Telemetry &amp; Team Velocity</a:t>
+            </a:r>
+          </a:p>
+        </p:txBody>
+      </p:sp>
+      <p:sp>
+        <p:nvSpPr>
+          <p:cNvPr id="7" name="TextBox 6"/>
+          <p:cNvSpPr txBox="1"/>
+          <p:nvPr/>
+        </p:nvSpPr>
+        <p:spPr>
+          <a:xfrm>
+            <a:off x="7772400" y="4846320"/>
+            <a:ext cx="1005840" cy="182880"/>
+          </a:xfrm>
+          <a:prstGeom prst="rect">
+            <a:avLst/>
+          </a:prstGeom>
+          <a:noFill/>
+        </p:spPr>
+        <p:txBody>
+          <a:bodyPr wrap="square" lIns="0" rIns="0" tIns="0" bIns="0" anchor="t">
+            <a:spAutoFit/>
+          </a:bodyPr>
+          <a:lstStyle/>
+          <a:p>
+            <a:pPr algn="r"/>
+            <a:r>
+              <a:rPr sz="800" b="0">
+                <a:solidFill>
+                  <a:srgbClr val="94A3B8"/>
+                </a:solidFill>
+                <a:latin typeface="Calibri"/>
+              </a:rPr>
+              <a:t>12 / 12</a:t>
+            </a:r>
+          </a:p>
+        </p:txBody>
+      </p:sp>
+      <p:graphicFrame>
+        <p:nvGraphicFramePr>
+          <p:cNvPr id="8" name="Table 7"/>
+          <p:cNvGraphicFramePr>
+            <a:graphicFrameLocks noGrp="1"/>
+          </p:cNvGraphicFramePr>
+          <p:nvPr/>
+        </p:nvGraphicFramePr>
+        <p:xfrm>
+          <a:off x="411480" y="1051560"/>
+          <a:ext cx="8321039" cy="2560320"/>
+        </p:xfrm>
+        <a:graphic>
+          <a:graphicData uri="http://schemas.openxmlformats.org/drawingml/2006/table">
+            <a:tbl>
+              <a:tblPr firstRow="1" bandRow="1">
+                <a:tableStyleId>{5C22544A-7EE6-4342-B048-85BDC9FD1C3A}</a:tableStyleId>
+              </a:tblPr>
+              <a:tblGrid>
+                <a:gridCol w="1109472"/>
+                <a:gridCol w="1201928"/>
+                <a:gridCol w="647192"/>
+                <a:gridCol w="5362447"/>
+              </a:tblGrid>
+              <a:tr h="365760">
+                <a:tc>
+                  <a:txBody>
+                    <a:bodyPr wrap="square"/>
+                    <a:lstStyle/>
+                    <a:p>
+                      <a:pPr algn="l"/>
+                      <a:r>
+                        <a:rPr sz="1100" b="1">
+                          <a:solidFill>
+                            <a:srgbClr val="F8FAFC"/>
+                          </a:solidFill>
+                          <a:latin typeface="Calibri"/>
+                        </a:rPr>
+                        <a:t>Phase</a:t>
+                      </a:r>
+                    </a:p>
+                  </a:txBody>
+                  <a:tcPr marL="73152" marR="73152" marT="36576" marB="36576" anchor="t">
+                    <a:solidFill>
+                      <a:srgbClr val="334155"/>
+                    </a:solidFill>
+                  </a:tcPr>
+                </a:tc>
+                <a:tc>
+                  <a:txBody>
+                    <a:bodyPr wrap="square"/>
+                    <a:lstStyle/>
+                    <a:p>
+                      <a:pPr algn="l"/>
+                      <a:r>
+                        <a:rPr sz="1100" b="1">
+                          <a:solidFill>
+                            <a:srgbClr val="F8FAFC"/>
+                          </a:solidFill>
+                          <a:latin typeface="Calibri"/>
+                        </a:rPr>
+                        <a:t>Upstream</a:t>
+                      </a:r>
+                    </a:p>
+                  </a:txBody>
+                  <a:tcPr marL="73152" marR="73152" marT="36576" marB="36576" anchor="t">
+                    <a:solidFill>
+                      <a:srgbClr val="334155"/>
+                    </a:solidFill>
+                  </a:tcPr>
+                </a:tc>
+                <a:tc>
+                  <a:txBody>
+                    <a:bodyPr wrap="square"/>
+                    <a:lstStyle/>
+                    <a:p>
+                      <a:pPr algn="l"/>
+                      <a:r>
+                        <a:rPr sz="1100" b="1">
+                          <a:solidFill>
+                            <a:srgbClr val="F8FAFC"/>
+                          </a:solidFill>
+                          <a:latin typeface="Calibri"/>
+                        </a:rPr>
+                        <a:t>Max Iter</a:t>
+                      </a:r>
+                    </a:p>
+                  </a:txBody>
+                  <a:tcPr marL="73152" marR="73152" marT="36576" marB="36576" anchor="t">
+                    <a:solidFill>
+                      <a:srgbClr val="334155"/>
+                    </a:solidFill>
+                  </a:tcPr>
+                </a:tc>
+                <a:tc>
+                  <a:txBody>
+                    <a:bodyPr wrap="square"/>
+                    <a:lstStyle/>
+                    <a:p>
+                      <a:pPr algn="l"/>
+                      <a:r>
+                        <a:rPr sz="1100" b="1">
+                          <a:solidFill>
+                            <a:srgbClr val="F8FAFC"/>
+                          </a:solidFill>
+                          <a:latin typeface="Calibri"/>
+                        </a:rPr>
+                        <a:t>Key Checks</a:t>
+                      </a:r>
+                    </a:p>
+                  </a:txBody>
+                  <a:tcPr marL="73152" marR="73152" marT="36576" marB="36576" anchor="t">
+                    <a:solidFill>
+                      <a:srgbClr val="334155"/>
+                    </a:solidFill>
+                  </a:tcPr>
+                </a:tc>
+              </a:tr>
+              <a:tr h="365760">
+                <a:tc>
+                  <a:txBody>
+                    <a:bodyPr wrap="square"/>
+                    <a:lstStyle/>
+                    <a:p>
+                      <a:pPr algn="l"/>
+                      <a:r>
+                        <a:rPr sz="900" b="0">
+                          <a:solidFill>
+                            <a:srgbClr val="CBD5E1"/>
+                          </a:solidFill>
+                          <a:latin typeface="Calibri"/>
+                        </a:rPr>
+                        <a:t>BRD</a:t>
+                      </a:r>
+                    </a:p>
+                  </a:txBody>
+                  <a:tcPr marL="73152" marR="73152" marT="36576" marB="36576" anchor="t">
+                    <a:solidFill>
+                      <a:srgbClr val="1E293B"/>
+                    </a:solidFill>
+                  </a:tcPr>
+                </a:tc>
+                <a:tc>
+                  <a:txBody>
+                    <a:bodyPr wrap="square"/>
+                    <a:lstStyle/>
+                    <a:p>
+                      <a:pPr algn="l"/>
+                      <a:r>
+                        <a:rPr sz="900" b="0">
+                          <a:solidFill>
+                            <a:srgbClr val="CBD5E1"/>
+                          </a:solidFill>
+                          <a:latin typeface="Calibri"/>
+                        </a:rPr>
+                        <a:t>None (root)</a:t>
+                      </a:r>
+                    </a:p>
+                  </a:txBody>
+                  <a:tcPr marL="73152" marR="73152" marT="36576" marB="36576" anchor="t">
+                    <a:solidFill>
+                      <a:srgbClr val="1E293B"/>
+                    </a:solidFill>
+                  </a:tcPr>
+                </a:tc>
+                <a:tc>
+                  <a:txBody>
+                    <a:bodyPr wrap="square"/>
+                    <a:lstStyle/>
+                    <a:p>
+                      <a:pPr algn="l"/>
+                      <a:r>
+                        <a:rPr sz="900" b="0">
+                          <a:solidFill>
+                            <a:srgbClr val="CBD5E1"/>
+                          </a:solidFill>
+                          <a:latin typeface="Calibri"/>
+                        </a:rPr>
+                        <a:t>3</a:t>
+                      </a:r>
+                    </a:p>
+                  </a:txBody>
+                  <a:tcPr marL="73152" marR="73152" marT="36576" marB="36576" anchor="t">
+                    <a:solidFill>
+                      <a:srgbClr val="1E293B"/>
+                    </a:solidFill>
+                  </a:tcPr>
+                </a:tc>
+                <a:tc>
+                  <a:txBody>
+                    <a:bodyPr wrap="square"/>
+                    <a:lstStyle/>
+                    <a:p>
+                      <a:pPr algn="l"/>
+                      <a:r>
+                        <a:rPr sz="900" b="0">
+                          <a:solidFill>
+                            <a:srgbClr val="CBD5E1"/>
+                          </a:solidFill>
+                          <a:latin typeface="Calibri"/>
+                        </a:rPr>
+                        <a:t>13 sections complete, &gt;= 3 quantified metrics,
+MVP maps to scope, &gt;= 2 alternatives</a:t>
+                      </a:r>
+                    </a:p>
+                  </a:txBody>
+                  <a:tcPr marL="73152" marR="73152" marT="36576" marB="36576" anchor="t">
+                    <a:solidFill>
+                      <a:srgbClr val="1E293B"/>
+                    </a:solidFill>
+                  </a:tcPr>
+                </a:tc>
+              </a:tr>
+              <a:tr h="365760">
+                <a:tc>
+                  <a:txBody>
+                    <a:bodyPr wrap="square"/>
+                    <a:lstStyle/>
+                    <a:p>
+                      <a:pPr algn="l"/>
+                      <a:r>
+                        <a:rPr sz="900" b="0">
+                          <a:solidFill>
+                            <a:srgbClr val="CBD5E1"/>
+                          </a:solidFill>
+                          <a:latin typeface="Calibri"/>
+                        </a:rPr>
+                        <a:t>Spec</a:t>
+                      </a:r>
+                    </a:p>
+                  </a:txBody>
+                  <a:tcPr marL="73152" marR="73152" marT="36576" marB="36576" anchor="t">
+                    <a:solidFill>
+                      <a:srgbClr val="162033"/>
+                    </a:solidFill>
+                  </a:tcPr>
+                </a:tc>
+                <a:tc>
+                  <a:txBody>
+                    <a:bodyPr wrap="square"/>
+                    <a:lstStyle/>
+                    <a:p>
+                      <a:pPr algn="l"/>
+                      <a:r>
+                        <a:rPr sz="900" b="0">
+                          <a:solidFill>
+                            <a:srgbClr val="CBD5E1"/>
+                          </a:solidFill>
+                          <a:latin typeface="Calibri"/>
+                        </a:rPr>
+                        <a:t>BRD goals</a:t>
+                      </a:r>
+                    </a:p>
+                  </a:txBody>
+                  <a:tcPr marL="73152" marR="73152" marT="36576" marB="36576" anchor="t">
+                    <a:solidFill>
+                      <a:srgbClr val="162033"/>
+                    </a:solidFill>
+                  </a:tcPr>
+                </a:tc>
+                <a:tc>
+                  <a:txBody>
+                    <a:bodyPr wrap="square"/>
+                    <a:lstStyle/>
+                    <a:p>
+                      <a:pPr algn="l"/>
+                      <a:r>
+                        <a:rPr sz="900" b="0">
+                          <a:solidFill>
+                            <a:srgbClr val="CBD5E1"/>
+                          </a:solidFill>
+                          <a:latin typeface="Calibri"/>
+                        </a:rPr>
+                        <a:t>3</a:t>
+                      </a:r>
+                    </a:p>
+                  </a:txBody>
+                  <a:tcPr marL="73152" marR="73152" marT="36576" marB="36576" anchor="t">
+                    <a:solidFill>
+                      <a:srgbClr val="162033"/>
+                    </a:solidFill>
+                  </a:tcPr>
+                </a:tc>
+                <a:tc>
+                  <a:txBody>
+                    <a:bodyPr wrap="square"/>
+                    <a:lstStyle/>
+                    <a:p>
+                      <a:pPr algn="l"/>
+                      <a:r>
+                        <a:rPr sz="900" b="0">
+                          <a:solidFill>
+                            <a:srgbClr val="CBD5E1"/>
+                          </a:solidFill>
+                          <a:latin typeface="Calibri"/>
+                        </a:rPr>
+                        <a:t>Every story -&gt; BRD goal, ACs testable,
+deps acyclic, features.json complete</a:t>
+                      </a:r>
+                    </a:p>
+                  </a:txBody>
+                  <a:tcPr marL="73152" marR="73152" marT="36576" marB="36576" anchor="t">
+                    <a:solidFill>
+                      <a:srgbClr val="162033"/>
+                    </a:solidFill>
+                  </a:tcPr>
+                </a:tc>
+              </a:tr>
+              <a:tr h="365760">
+                <a:tc>
+                  <a:txBody>
+                    <a:bodyPr wrap="square"/>
+                    <a:lstStyle/>
+                    <a:p>
+                      <a:pPr algn="l"/>
+                      <a:r>
+                        <a:rPr sz="900" b="0">
+                          <a:solidFill>
+                            <a:srgbClr val="CBD5E1"/>
+                          </a:solidFill>
+                          <a:latin typeface="Calibri"/>
+                        </a:rPr>
+                        <a:t>Design</a:t>
+                      </a:r>
+                    </a:p>
+                  </a:txBody>
+                  <a:tcPr marL="73152" marR="73152" marT="36576" marB="36576" anchor="t">
+                    <a:solidFill>
+                      <a:srgbClr val="1E293B"/>
+                    </a:solidFill>
+                  </a:tcPr>
+                </a:tc>
+                <a:tc>
+                  <a:txBody>
+                    <a:bodyPr wrap="square"/>
+                    <a:lstStyle/>
+                    <a:p>
+                      <a:pPr algn="l"/>
+                      <a:r>
+                        <a:rPr sz="900" b="0">
+                          <a:solidFill>
+                            <a:srgbClr val="CBD5E1"/>
+                          </a:solidFill>
+                          <a:latin typeface="Calibri"/>
+                        </a:rPr>
+                        <a:t>Spec stories</a:t>
+                      </a:r>
+                    </a:p>
+                  </a:txBody>
+                  <a:tcPr marL="73152" marR="73152" marT="36576" marB="36576" anchor="t">
+                    <a:solidFill>
+                      <a:srgbClr val="1E293B"/>
+                    </a:solidFill>
+                  </a:tcPr>
+                </a:tc>
+                <a:tc>
+                  <a:txBody>
+                    <a:bodyPr wrap="square"/>
+                    <a:lstStyle/>
+                    <a:p>
+                      <a:pPr algn="l"/>
+                      <a:r>
+                        <a:rPr sz="900" b="0">
+                          <a:solidFill>
+                            <a:srgbClr val="CBD5E1"/>
+                          </a:solidFill>
+                          <a:latin typeface="Calibri"/>
+                        </a:rPr>
+                        <a:t>3</a:t>
+                      </a:r>
+                    </a:p>
+                  </a:txBody>
+                  <a:tcPr marL="73152" marR="73152" marT="36576" marB="36576" anchor="t">
+                    <a:solidFill>
+                      <a:srgbClr val="1E293B"/>
+                    </a:solidFill>
+                  </a:tcPr>
+                </a:tc>
+                <a:tc>
+                  <a:txBody>
+                    <a:bodyPr wrap="square"/>
+                    <a:lstStyle/>
+                    <a:p>
+                      <a:pPr algn="l"/>
+                      <a:r>
+                        <a:rPr sz="900" b="0">
+                          <a:solidFill>
+                            <a:srgbClr val="CBD5E1"/>
+                          </a:solidFill>
+                          <a:latin typeface="Calibri"/>
+                        </a:rPr>
+                        <a:t>Component-map covers all stories,
+schemas valid, mockup fields match API</a:t>
+                      </a:r>
+                    </a:p>
+                  </a:txBody>
+                  <a:tcPr marL="73152" marR="73152" marT="36576" marB="36576" anchor="t">
+                    <a:solidFill>
+                      <a:srgbClr val="1E293B"/>
+                    </a:solidFill>
+                  </a:tcPr>
+                </a:tc>
+              </a:tr>
+              <a:tr h="365760">
+                <a:tc>
+                  <a:txBody>
+                    <a:bodyPr wrap="square"/>
+                    <a:lstStyle/>
+                    <a:p>
+                      <a:pPr algn="l"/>
+                      <a:r>
+                        <a:rPr sz="900" b="0">
+                          <a:solidFill>
+                            <a:srgbClr val="CBD5E1"/>
+                          </a:solidFill>
+                          <a:latin typeface="Calibri"/>
+                        </a:rPr>
+                        <a:t>Brownfield</a:t>
+                      </a:r>
+                    </a:p>
+                  </a:txBody>
+                  <a:tcPr marL="73152" marR="73152" marT="36576" marB="36576" anchor="t">
+                    <a:solidFill>
+                      <a:srgbClr val="162033"/>
+                    </a:solidFill>
+                  </a:tcPr>
+                </a:tc>
+                <a:tc>
+                  <a:txBody>
+                    <a:bodyPr wrap="square"/>
+                    <a:lstStyle/>
+                    <a:p>
+                      <a:pPr algn="l"/>
+                      <a:r>
+                        <a:rPr sz="900" b="0">
+                          <a:solidFill>
+                            <a:srgbClr val="CBD5E1"/>
+                          </a:solidFill>
+                          <a:latin typeface="Calibri"/>
+                        </a:rPr>
+                        <a:t>Codebase</a:t>
+                      </a:r>
+                    </a:p>
+                  </a:txBody>
+                  <a:tcPr marL="73152" marR="73152" marT="36576" marB="36576" anchor="t">
+                    <a:solidFill>
+                      <a:srgbClr val="162033"/>
+                    </a:solidFill>
+                  </a:tcPr>
+                </a:tc>
+                <a:tc>
+                  <a:txBody>
+                    <a:bodyPr wrap="square"/>
+                    <a:lstStyle/>
+                    <a:p>
+                      <a:pPr algn="l"/>
+                      <a:r>
+                        <a:rPr sz="900" b="0">
+                          <a:solidFill>
+                            <a:srgbClr val="CBD5E1"/>
+                          </a:solidFill>
+                          <a:latin typeface="Calibri"/>
+                        </a:rPr>
+                        <a:t>2</a:t>
+                      </a:r>
+                    </a:p>
+                  </a:txBody>
+                  <a:tcPr marL="73152" marR="73152" marT="36576" marB="36576" anchor="t">
+                    <a:solidFill>
+                      <a:srgbClr val="162033"/>
+                    </a:solidFill>
+                  </a:tcPr>
+                </a:tc>
+                <a:tc>
+                  <a:txBody>
+                    <a:bodyPr wrap="square"/>
+                    <a:lstStyle/>
+                    <a:p>
+                      <a:pPr algn="l"/>
+                      <a:r>
+                        <a:rPr sz="900" b="0">
+                          <a:solidFill>
+                            <a:srgbClr val="CBD5E1"/>
+                          </a:solidFill>
+                          <a:latin typeface="Calibri"/>
+                        </a:rPr>
+                        <a:t>Modules exist in repo, evidence-cited,
+coupling matches graph, concrete strategy</a:t>
+                      </a:r>
+                    </a:p>
+                  </a:txBody>
+                  <a:tcPr marL="73152" marR="73152" marT="36576" marB="36576" anchor="t">
+                    <a:solidFill>
+                      <a:srgbClr val="162033"/>
+                    </a:solidFill>
+                  </a:tcPr>
+                </a:tc>
+              </a:tr>
+              <a:tr h="365760">
+                <a:tc>
+                  <a:txBody>
+                    <a:bodyPr wrap="square"/>
+                    <a:lstStyle/>
+                    <a:p>
+                      <a:pPr algn="l"/>
+                      <a:r>
+                        <a:rPr sz="900" b="0">
+                          <a:solidFill>
+                            <a:srgbClr val="CBD5E1"/>
+                          </a:solidFill>
+                          <a:latin typeface="Calibri"/>
+                        </a:rPr>
+                        <a:t>Seam-Finder</a:t>
+                      </a:r>
+                    </a:p>
+                  </a:txBody>
+                  <a:tcPr marL="73152" marR="73152" marT="36576" marB="36576" anchor="t">
+                    <a:solidFill>
+                      <a:srgbClr val="1E293B"/>
+                    </a:solidFill>
+                  </a:tcPr>
+                </a:tc>
+                <a:tc>
+                  <a:txBody>
+                    <a:bodyPr wrap="square"/>
+                    <a:lstStyle/>
+                    <a:p>
+                      <a:pPr algn="l"/>
+                      <a:r>
+                        <a:rPr sz="900" b="0">
+                          <a:solidFill>
+                            <a:srgbClr val="CBD5E1"/>
+                          </a:solidFill>
+                          <a:latin typeface="Calibri"/>
+                        </a:rPr>
+                        <a:t>code-graph.json</a:t>
+                      </a:r>
+                    </a:p>
+                  </a:txBody>
+                  <a:tcPr marL="73152" marR="73152" marT="36576" marB="36576" anchor="t">
+                    <a:solidFill>
+                      <a:srgbClr val="1E293B"/>
+                    </a:solidFill>
+                  </a:tcPr>
+                </a:tc>
+                <a:tc>
+                  <a:txBody>
+                    <a:bodyPr wrap="square"/>
+                    <a:lstStyle/>
+                    <a:p>
+                      <a:pPr algn="l"/>
+                      <a:r>
+                        <a:rPr sz="900" b="0">
+                          <a:solidFill>
+                            <a:srgbClr val="CBD5E1"/>
+                          </a:solidFill>
+                          <a:latin typeface="Calibri"/>
+                        </a:rPr>
+                        <a:t>2</a:t>
+                      </a:r>
+                    </a:p>
+                  </a:txBody>
+                  <a:tcPr marL="73152" marR="73152" marT="36576" marB="36576" anchor="t">
+                    <a:solidFill>
+                      <a:srgbClr val="1E293B"/>
+                    </a:solidFill>
+                  </a:tcPr>
+                </a:tc>
+                <a:tc>
+                  <a:txBody>
+                    <a:bodyPr wrap="square"/>
+                    <a:lstStyle/>
+                    <a:p>
+                      <a:pPr algn="l"/>
+                      <a:r>
+                        <a:rPr sz="900" b="0">
+                          <a:solidFill>
+                            <a:srgbClr val="CBD5E1"/>
+                          </a:solidFill>
+                          <a:latin typeface="Calibri"/>
+                        </a:rPr>
+                        <a:t>Top 3 candidates exist in code,
+3 axes scored, independent cut-points</a:t>
+                      </a:r>
+                    </a:p>
+                  </a:txBody>
+                  <a:tcPr marL="73152" marR="73152" marT="36576" marB="36576" anchor="t">
+                    <a:solidFill>
+                      <a:srgbClr val="1E293B"/>
+                    </a:solidFill>
+                  </a:tcPr>
+                </a:tc>
+              </a:tr>
+              <a:tr h="365760">
+                <a:tc>
+                  <a:txBody>
+                    <a:bodyPr wrap="square"/>
+                    <a:lstStyle/>
+                    <a:p>
+                      <a:pPr algn="l"/>
+                      <a:r>
+                        <a:rPr sz="900" b="0">
+                          <a:solidFill>
+                            <a:srgbClr val="CBD5E1"/>
+                          </a:solidFill>
+                          <a:latin typeface="Calibri"/>
+                        </a:rPr>
+                        <a:t>Deploy</a:t>
+                      </a:r>
+                    </a:p>
+                  </a:txBody>
+                  <a:tcPr marL="73152" marR="73152" marT="36576" marB="36576" anchor="t">
+                    <a:solidFill>
+                      <a:srgbClr val="162033"/>
+                    </a:solidFill>
+                  </a:tcPr>
+                </a:tc>
+                <a:tc>
+                  <a:txBody>
+                    <a:bodyPr wrap="square"/>
+                    <a:lstStyle/>
+                    <a:p>
+                      <a:pPr algn="l"/>
+                      <a:r>
+                        <a:rPr sz="900" b="0">
+                          <a:solidFill>
+                            <a:srgbClr val="CBD5E1"/>
+                          </a:solidFill>
+                          <a:latin typeface="Calibri"/>
+                        </a:rPr>
+                        <a:t>system-design.md</a:t>
+                      </a:r>
+                    </a:p>
+                  </a:txBody>
+                  <a:tcPr marL="73152" marR="73152" marT="36576" marB="36576" anchor="t">
+                    <a:solidFill>
+                      <a:srgbClr val="162033"/>
+                    </a:solidFill>
+                  </a:tcPr>
+                </a:tc>
+                <a:tc>
+                  <a:txBody>
+                    <a:bodyPr wrap="square"/>
+                    <a:lstStyle/>
+                    <a:p>
+                      <a:pPr algn="l"/>
+                      <a:r>
+                        <a:rPr sz="900" b="0">
+                          <a:solidFill>
+                            <a:srgbClr val="CBD5E1"/>
+                          </a:solidFill>
+                          <a:latin typeface="Calibri"/>
+                        </a:rPr>
+                        <a:t>2</a:t>
+                      </a:r>
+                    </a:p>
+                  </a:txBody>
+                  <a:tcPr marL="73152" marR="73152" marT="36576" marB="36576" anchor="t">
+                    <a:solidFill>
+                      <a:srgbClr val="162033"/>
+                    </a:solidFill>
+                  </a:tcPr>
+                </a:tc>
+                <a:tc>
+                  <a:txBody>
+                    <a:bodyPr wrap="square"/>
+                    <a:lstStyle/>
+                    <a:p>
+                      <a:pPr algn="l"/>
+                      <a:r>
+                        <a:rPr sz="900" b="0">
+                          <a:solidFill>
+                            <a:srgbClr val="CBD5E1"/>
+                          </a:solidFill>
+                          <a:latin typeface="Calibri"/>
+                        </a:rPr>
+                        <a:t>Services match design, no port conflicts,
+health checks defined, init.sh complete</a:t>
+                      </a:r>
+                    </a:p>
+                  </a:txBody>
+                  <a:tcPr marL="73152" marR="73152" marT="36576" marB="36576" anchor="t">
+                    <a:solidFill>
+                      <a:srgbClr val="162033"/>
+                    </a:solidFill>
+                  </a:tcPr>
+                </a:tc>
+              </a:tr>
+            </a:tbl>
+          </a:graphicData>
+        </a:graphic>
+      </p:graphicFrame>
+      <p:sp>
+        <p:nvSpPr>
+          <p:cNvPr id="9" name="Rounded Rectangle 8"/>
+          <p:cNvSpPr/>
+          <p:nvPr/>
+        </p:nvSpPr>
+        <p:spPr>
+          <a:xfrm>
+            <a:off x="411480" y="3749039"/>
+            <a:ext cx="8321040" cy="502920"/>
+          </a:xfrm>
+          <a:prstGeom prst="roundRect">
+            <a:avLst>
+              <a:gd name="adj" fmla="val 10000"/>
+            </a:avLst>
+          </a:prstGeom>
+          <a:solidFill>
+            <a:srgbClr val="0C4A6E"/>
+          </a:solidFill>
+          <a:ln w="12700">
+            <a:solidFill>
+              <a:srgbClr val="38BDF8"/>
+            </a:solidFill>
+          </a:ln>
+        </p:spPr>
+        <p:style>
+          <a:lnRef idx="1">
+            <a:schemeClr val="accent1"/>
+          </a:lnRef>
+          <a:fillRef idx="3">
+            <a:schemeClr val="accent1"/>
+          </a:fillRef>
+          <a:effectRef idx="2">
+            <a:schemeClr val="accent1"/>
+          </a:effectRef>
+          <a:fontRef idx="minor">
+            <a:schemeClr val="lt1"/>
+          </a:fontRef>
+        </p:style>
+        <p:txBody>
+          <a:bodyPr rtlCol="0" anchor="ctr"/>
+          <a:lstStyle/>
+          <a:p>
+            <a:pPr algn="ctr"/>
+          </a:p>
+        </p:txBody>
+      </p:sp>
+      <p:sp>
+        <p:nvSpPr>
+          <p:cNvPr id="10" name="TextBox 9"/>
+          <p:cNvSpPr txBox="1"/>
+          <p:nvPr/>
+        </p:nvSpPr>
+        <p:spPr>
+          <a:xfrm>
+            <a:off x="594360" y="3840479"/>
+            <a:ext cx="7955279" cy="320040"/>
+          </a:xfrm>
+          <a:prstGeom prst="rect">
+            <a:avLst/>
+          </a:prstGeom>
+          <a:noFill/>
+        </p:spPr>
+        <p:txBody>
+          <a:bodyPr wrap="square" lIns="0" rIns="0" tIns="0" bIns="0" anchor="ctr">
+            <a:spAutoFit/>
+          </a:bodyPr>
+          <a:lstStyle/>
+          <a:p>
+            <a:pPr algn="l"/>
+            <a:r>
+              <a:rPr sz="1100" b="1">
+                <a:solidFill>
+                  <a:srgbClr val="F8FAFC"/>
+                </a:solidFill>
+                <a:latin typeface="Calibri"/>
+              </a:rPr>
+              <a:t>5 criteria (completeness, traceability, specificity, consistency, actionability) · Pass: avg &gt;= 7.0 AND all &gt;= 5 · Ratchet: score[i] &gt;= score[i-1] always</a:t>
+            </a:r>
+          </a:p>
+        </p:txBody>
+      </p:sp>
+      <p:sp>
+        <p:nvSpPr>
+          <p:cNvPr id="11" name="TextBox 10"/>
+          <p:cNvSpPr txBox="1"/>
+          <p:nvPr/>
+        </p:nvSpPr>
+        <p:spPr>
+          <a:xfrm>
+            <a:off x="411480" y="4343400"/>
+            <a:ext cx="8321040" cy="182880"/>
+          </a:xfrm>
+          <a:prstGeom prst="rect">
+            <a:avLst/>
+          </a:prstGeom>
+          <a:noFill/>
+        </p:spPr>
+        <p:txBody>
+          <a:bodyPr wrap="square" lIns="0" rIns="0" tIns="0" bIns="0" anchor="t">
+            <a:spAutoFit/>
+          </a:bodyPr>
+          <a:lstStyle/>
+          <a:p>
+            <a:pPr algn="l"/>
+            <a:r>
+              <a:rPr sz="800" b="0">
+                <a:solidFill>
+                  <a:srgbClr val="94A3B8"/>
+                </a:solidFill>
+                <a:latin typeface="Calibri"/>
+              </a:rPr>
+              <a:t>Telemetry: harness_phase_eval_score + harness_phase_eval_iterations_total · 4 Grafana panels in Phase Quality section</a:t>
             </a:r>
           </a:p>
         </p:txBody>
@@ -6346,7 +7400,7 @@
                 </a:solidFill>
                 <a:latin typeface="Calibri"/>
               </a:rPr>
-              <a:t>2 / 11</a:t>
+              <a:t>2 / 12</a:t>
             </a:r>
           </a:p>
         </p:txBody>
@@ -7850,7 +8904,7 @@
                 </a:solidFill>
                 <a:latin typeface="Calibri"/>
               </a:rPr>
-              <a:t>3 / 11</a:t>
+              <a:t>3 / 12</a:t>
             </a:r>
           </a:p>
         </p:txBody>
@@ -10084,7 +11138,7 @@
                 </a:solidFill>
                 <a:latin typeface="Calibri"/>
               </a:rPr>
-              <a:t>4 / 11</a:t>
+              <a:t>4 / 12</a:t>
             </a:r>
           </a:p>
         </p:txBody>
@@ -11349,7 +12403,7 @@
                 </a:solidFill>
                 <a:latin typeface="Calibri"/>
               </a:rPr>
-              <a:t>5 / 11</a:t>
+              <a:t>5 / 12</a:t>
             </a:r>
           </a:p>
         </p:txBody>
@@ -12393,7 +13447,7 @@
                 </a:solidFill>
                 <a:latin typeface="Calibri"/>
               </a:rPr>
-              <a:t>6 / 11</a:t>
+              <a:t>6 / 12</a:t>
             </a:r>
           </a:p>
         </p:txBody>
@@ -13669,7 +14723,7 @@
                 </a:solidFill>
                 <a:latin typeface="Calibri"/>
               </a:rPr>
-              <a:t>7 / 11</a:t>
+              <a:t>7 / 12</a:t>
             </a:r>
           </a:p>
         </p:txBody>
@@ -17111,7 +18165,7 @@
                 </a:solidFill>
                 <a:latin typeface="Calibri"/>
               </a:rPr>
-              <a:t>8 / 11</a:t>
+              <a:t>8 / 12</a:t>
             </a:r>
           </a:p>
         </p:txBody>
@@ -18198,7 +19252,7 @@
                 </a:solidFill>
                 <a:latin typeface="Calibri"/>
               </a:rPr>
-              <a:t>9 / 11</a:t>
+              <a:t>9 / 12</a:t>
             </a:r>
           </a:p>
         </p:txBody>

</xml_diff>